<commit_message>
add buildx to exercise and fix ppt errors
</commit_message>
<xml_diff>
--- a/sample-app/fortune-cookies.pptx
+++ b/sample-app/fortune-cookies.pptx
@@ -15616,12 +15616,8 @@
           <a:lstStyle/>
           <a:p>
             <a:r>
-              <a:rPr lang="en-US" dirty="0" err="1"/>
-              <a:t>Bulletinboard</a:t>
-            </a:r>
-            <a:r>
-              <a:rPr lang="en-US" dirty="0"/>
-              <a:t> in K8s: Target picture overall</a:t>
+              <a:rPr lang="en-US" dirty="0"/>
+              <a:t>Fortune Cookies in K8s: Target picture overall</a:t>
             </a:r>
           </a:p>
         </p:txBody>

</xml_diff>